<commit_message>
Growth slide: state the period in months
Co-Authored-By: Claude Fable 5.1 <noreply@anthropic.com>
</commit_message>
<xml_diff>
--- a/Growth Report/Catalyst_Growth_Slide.pptx
+++ b/Growth Report/Catalyst_Growth_Slide.pptx
@@ -1108,7 +1108,7 @@
                 <a:ea typeface="Arial" pitchFamily="34" charset="-122"/>
                 <a:cs typeface="Arial" pitchFamily="34" charset="-120"/>
               </a:rPr>
-              <a:t>in 33 weeks</a:t>
+              <a:t>in 8 months</a:t>
             </a:r>
             <a:endParaRPr lang="en-US" sz="1050" dirty="0"/>
           </a:p>
@@ -1266,7 +1266,7 @@
                 <a:ea typeface="Arial" pitchFamily="34" charset="-122"/>
                 <a:cs typeface="Arial" pitchFamily="34" charset="-120"/>
               </a:rPr>
-              <a:t>2.9 Units per Store per week in first 33 weeks with ASP 52% higher than #1 selling cat litter SKU</a:t>
+              <a:t>2.9 Units per Store per week in first 8 months with ASP 52% higher than #1 selling cat litter SKU</a:t>
             </a:r>
             <a:endParaRPr lang="en-US" sz="1550" dirty="0"/>
           </a:p>

</xml_diff>